<commit_message>
fix(case-study): visual QA pass — chart redesign, funnel overflow, page-number placement
Subagent visual QA caught four real issues, all fixed:
- Slide 5: replaced mixed-scale chart (which rendered 0-value
  bars for the irrelevant attention/allowlist categories) with
  a clean Week-1 / Full-flight / Week-3 PGAM-vs-IAB completion
  comparison + matched +6.6pp callout
- Slide 9: LOWER FUNNEL card body was clipping because the
  narrow 7" card had only 2.5" for body text — widened body,
  narrowed status block, bumped card height to 1.5"
- Slide 1: subtitle and right-panel card both now say 3.94M
- Slide 11: page number moved out of the contact card into
  slide chrome

Co-Authored-By: Claude Opus 4.7 <noreply@anthropic.com>
</commit_message>
<xml_diff>
--- a/case_study_deck/PGAM_Case_Study_Amazon_Business_OLV.pptx
+++ b/case_study_deck/PGAM_Case_Study_Amazon_Business_OLV.pptx
@@ -122,7 +122,36 @@
   <c:date1904 val="0"/>
   <c:roundedCorners val="1"/>
   <c:chart>
-    <c:autoTitleDeleted val="1"/>
+    <c:title>
+      <c:tx>
+        <c:rich>
+          <a:bodyPr/>
+          <a:lstStyle/>
+          <a:p>
+            <a:pPr>
+              <a:defRPr sz="1200" b="0" i="0" u="none" strike="noStrike">
+                <a:solidFill>
+                  <a:srgbClr val="64748B"/>
+                </a:solidFill>
+                <a:latin typeface="Calibri"/>
+              </a:defRPr>
+            </a:pPr>
+            <a:r>
+              <a:rPr sz="1200" b="0" i="0" u="none" strike="noStrike">
+                <a:solidFill>
+                  <a:srgbClr val="64748B"/>
+                </a:solidFill>
+                <a:latin typeface="Calibri"/>
+              </a:rPr>
+              <a:t>Video completion rate (%) — PGAM vs IAB OLV benchmark</a:t>
+            </a:r>
+          </a:p>
+        </c:rich>
+      </c:tx>
+      <c:layout/>
+      <c:overlay val="0"/>
+    </c:title>
+    <c:autoTitleDeleted val="0"/>
     <c:plotArea>
       <c:layout/>
       <c:barChart>
@@ -181,13 +210,13 @@
                 <c:ptCount val="3"/>
                 <c:lvl>
                   <c:pt idx="0">
-                    <c:v>Completion rate</c:v>
+                    <c:v>Week 1</c:v>
                   </c:pt>
                   <c:pt idx="1">
-                    <c:v>Attention score (PGAM)</c:v>
+                    <c:v>Full flight to date</c:v>
                   </c:pt>
                   <c:pt idx="2">
-                    <c:v>Allowlisted supply</c:v>
+                    <c:v>Week 3</c:v>
                   </c:pt>
                 </c:lvl>
               </c:multiLvlStrCache>
@@ -200,13 +229,13 @@
                 <c:formatCode>General</c:formatCode>
                 <c:ptCount val="3"/>
                 <c:pt idx="0">
+                  <c:v>64.6</c:v>
+                </c:pt>
+                <c:pt idx="1">
                   <c:v>66.5</c:v>
                 </c:pt>
-                <c:pt idx="1">
-                  <c:v>60.5</c:v>
-                </c:pt>
                 <c:pt idx="2">
-                  <c:v>100</c:v>
+                  <c:v>70.6</c:v>
                 </c:pt>
               </c:numCache>
             </c:numRef>
@@ -221,7 +250,7 @@
               <c:strCache>
                 <c:ptCount val="1"/>
                 <c:pt idx="0">
-                  <c:v>IAB OLV benchmark</c:v>
+                  <c:v>IAB OLV benchmark (avg)</c:v>
                 </c:pt>
               </c:strCache>
             </c:strRef>
@@ -264,13 +293,13 @@
                 <c:ptCount val="3"/>
                 <c:lvl>
                   <c:pt idx="0">
-                    <c:v>Completion rate</c:v>
+                    <c:v>Week 1</c:v>
                   </c:pt>
                   <c:pt idx="1">
-                    <c:v>Attention score (PGAM)</c:v>
+                    <c:v>Full flight to date</c:v>
                   </c:pt>
                   <c:pt idx="2">
-                    <c:v>Allowlisted supply</c:v>
+                    <c:v>Week 3</c:v>
                   </c:pt>
                 </c:lvl>
               </c:multiLvlStrCache>
@@ -286,10 +315,10 @@
                   <c:v>64</c:v>
                 </c:pt>
                 <c:pt idx="1">
-                  <c:v>0</c:v>
+                  <c:v>64</c:v>
                 </c:pt>
                 <c:pt idx="2">
-                  <c:v>0</c:v>
+                  <c:v>64</c:v>
                 </c:pt>
               </c:numCache>
             </c:numRef>
@@ -319,7 +348,7 @@
           <c:showBubbleSize val="0"/>
           <c:showLeaderLines val="0"/>
         </c:dLbls>
-        <c:gapWidth val="80"/>
+        <c:gapWidth val="90"/>
         <c:overlap val="0"/>
         <c:axId val="2094734554"/>
         <c:axId val="2094734552"/>
@@ -350,7 +379,7 @@
           <a:lstStyle/>
           <a:p>
             <a:pPr>
-              <a:defRPr sz="1100" b="0" i="0" u="none" strike="noStrike">
+              <a:defRPr sz="1200" b="0" i="0" u="none" strike="noStrike">
                 <a:solidFill>
                   <a:srgbClr val="0B1E3F"/>
                 </a:solidFill>
@@ -370,6 +399,8 @@
         <c:axId val="2094734552"/>
         <c:scaling>
           <c:orientation val="minMax"/>
+          <c:max val="75"/>
+          <c:min val="55"/>
         </c:scaling>
         <c:delete val="0"/>
         <c:axPos val="l"/>
@@ -2665,7 +2696,7 @@
                 <a:ea typeface="Calibri" pitchFamily="34" charset="-122"/>
                 <a:cs typeface="Calibri" pitchFamily="34" charset="-120"/>
               </a:rPr>
-              <a:t>How PGAM delivered 3.9M premium impressions and a 66.5% video completion rate for Amazon Business — above the IAB OLV benchmark.</a:t>
+              <a:t>How PGAM delivered 3.94M premium impressions and a 66.5% video completion rate for Amazon Business — above the IAB OLV benchmark.</a:t>
             </a:r>
             <a:endParaRPr lang="en-US" sz="1600" dirty="0"/>
           </a:p>
@@ -2846,7 +2877,7 @@
                 <a:ea typeface="Georgia" pitchFamily="34" charset="-122"/>
                 <a:cs typeface="Georgia" pitchFamily="34" charset="-120"/>
               </a:rPr>
-              <a:t>3.9M</a:t>
+              <a:t>3.94M</a:t>
             </a:r>
             <a:endParaRPr lang="en-US" sz="2800" dirty="0"/>
           </a:p>
@@ -2885,24 +2916,7 @@
                 <a:ea typeface="Calibri" pitchFamily="34" charset="-122"/>
                 <a:cs typeface="Calibri" pitchFamily="34" charset="-120"/>
               </a:rPr>
-              <a:t>Premium</a:t>
-            </a:r>
-            <a:endParaRPr lang="en-US" sz="1100" dirty="0"/>
-          </a:p>
-          <a:p>
-            <a:pPr indent="0" marL="0">
-              <a:buNone/>
-            </a:pPr>
-            <a:r>
-              <a:rPr lang="en-US" sz="1100" dirty="0">
-                <a:solidFill>
-                  <a:srgbClr val="CADCFC"/>
-                </a:solidFill>
-                <a:latin typeface="Calibri" pitchFamily="34" charset="0"/>
-                <a:ea typeface="Calibri" pitchFamily="34" charset="-122"/>
-                <a:cs typeface="Calibri" pitchFamily="34" charset="-120"/>
-              </a:rPr>
-              <a:t>impressions</a:t>
+              <a:t>Premium impressions</a:t>
             </a:r>
             <a:endParaRPr lang="en-US" sz="1100" dirty="0"/>
           </a:p>
@@ -3005,24 +3019,7 @@
                 <a:ea typeface="Calibri" pitchFamily="34" charset="-122"/>
                 <a:cs typeface="Calibri" pitchFamily="34" charset="-120"/>
               </a:rPr>
-              <a:t>Video</a:t>
-            </a:r>
-            <a:endParaRPr lang="en-US" sz="1100" dirty="0"/>
-          </a:p>
-          <a:p>
-            <a:pPr indent="0" marL="0">
-              <a:buNone/>
-            </a:pPr>
-            <a:r>
-              <a:rPr lang="en-US" sz="1100" dirty="0">
-                <a:solidFill>
-                  <a:srgbClr val="CADCFC"/>
-                </a:solidFill>
-                <a:latin typeface="Calibri" pitchFamily="34" charset="0"/>
-                <a:ea typeface="Calibri" pitchFamily="34" charset="-122"/>
-                <a:cs typeface="Calibri" pitchFamily="34" charset="-120"/>
-              </a:rPr>
-              <a:t>completion rate</a:t>
+              <a:t>Video completion rate</a:t>
             </a:r>
             <a:endParaRPr lang="en-US" sz="1100" dirty="0"/>
           </a:p>
@@ -3125,24 +3122,7 @@
                 <a:ea typeface="Calibri" pitchFamily="34" charset="-122"/>
                 <a:cs typeface="Calibri" pitchFamily="34" charset="-120"/>
               </a:rPr>
-              <a:t>Vetted</a:t>
-            </a:r>
-            <a:endParaRPr lang="en-US" sz="1100" dirty="0"/>
-          </a:p>
-          <a:p>
-            <a:pPr indent="0" marL="0">
-              <a:buNone/>
-            </a:pPr>
-            <a:r>
-              <a:rPr lang="en-US" sz="1100" dirty="0">
-                <a:solidFill>
-                  <a:srgbClr val="CADCFC"/>
-                </a:solidFill>
-                <a:latin typeface="Calibri" pitchFamily="34" charset="0"/>
-                <a:ea typeface="Calibri" pitchFamily="34" charset="-122"/>
-                <a:cs typeface="Calibri" pitchFamily="34" charset="-120"/>
-              </a:rPr>
-              <a:t>publishers</a:t>
+              <a:t>Vetted publishers</a:t>
             </a:r>
             <a:endParaRPr lang="en-US" sz="1100" dirty="0"/>
           </a:p>
@@ -4608,8 +4588,8 @@
         </p:nvSpPr>
         <p:spPr>
           <a:xfrm>
-            <a:off x="914400" y="5669280"/>
-            <a:ext cx="10332720" cy="777240"/>
+            <a:off x="914400" y="5577840"/>
+            <a:ext cx="8686800" cy="777240"/>
           </a:xfrm>
           <a:prstGeom prst="rect">
             <a:avLst/>
@@ -4633,8 +4613,8 @@
         </p:nvSpPr>
         <p:spPr>
           <a:xfrm>
-            <a:off x="1097280" y="5760720"/>
-            <a:ext cx="4572000" cy="320040"/>
+            <a:off x="1097280" y="5669280"/>
+            <a:ext cx="5486400" cy="320040"/>
           </a:xfrm>
           <a:prstGeom prst="rect">
             <a:avLst/>
@@ -4672,8 +4652,8 @@
         </p:nvSpPr>
         <p:spPr>
           <a:xfrm>
-            <a:off x="1097280" y="6080760"/>
-            <a:ext cx="6400800" cy="274320"/>
+            <a:off x="1097280" y="5989320"/>
+            <a:ext cx="7315200" cy="274320"/>
           </a:xfrm>
           <a:prstGeom prst="rect">
             <a:avLst/>
@@ -4711,8 +4691,8 @@
         </p:nvSpPr>
         <p:spPr>
           <a:xfrm>
-            <a:off x="10180015" y="5989320"/>
-            <a:ext cx="914400" cy="274320"/>
+            <a:off x="10545775" y="6528816"/>
+            <a:ext cx="1097280" cy="274320"/>
           </a:xfrm>
           <a:prstGeom prst="rect">
             <a:avLst/>
@@ -5596,7 +5576,7 @@
         </p:nvSpPr>
         <p:spPr>
           <a:xfrm>
-            <a:off x="777240" y="4069080"/>
+            <a:off x="777240" y="4114800"/>
             <a:ext cx="3657600" cy="274320"/>
           </a:xfrm>
           <a:prstGeom prst="rect">
@@ -5606,7 +5586,7 @@
           <a:ln/>
         </p:spPr>
         <p:txBody>
-          <a:bodyPr wrap="square" rtlCol="0" anchor="ctr"/>
+          <a:bodyPr wrap="square" lIns="0" tIns="0" rIns="0" bIns="0" rtlCol="0" anchor="ctr"/>
           <a:lstStyle/>
           <a:p>
             <a:pPr indent="0" marL="0">
@@ -5635,17 +5615,17 @@
         </p:nvSpPr>
         <p:spPr>
           <a:xfrm>
-            <a:off x="777240" y="4389120"/>
-            <a:ext cx="10637215" cy="1737360"/>
-          </a:xfrm>
-          <a:prstGeom prst="rect">
-            <a:avLst/>
-          </a:prstGeom>
-          <a:noFill/>
-          <a:ln/>
-        </p:spPr>
-        <p:txBody>
-          <a:bodyPr wrap="square" rtlCol="0" anchor="ctr"/>
+            <a:off x="777240" y="4480560"/>
+            <a:ext cx="10637215" cy="1645920"/>
+          </a:xfrm>
+          <a:prstGeom prst="rect">
+            <a:avLst/>
+          </a:prstGeom>
+          <a:noFill/>
+          <a:ln/>
+        </p:spPr>
+        <p:txBody>
+          <a:bodyPr wrap="square" lIns="0" tIns="0" rIns="0" bIns="0" rtlCol="0" anchor="t"/>
           <a:lstStyle/>
           <a:p>
             <a:pPr indent="0" marL="0">
@@ -5663,7 +5643,7 @@
                 <a:ea typeface="Calibri" pitchFamily="34" charset="-122"/>
                 <a:cs typeface="Calibri" pitchFamily="34" charset="-120"/>
               </a:rPr>
-              <a:t>Amazon Business' Q2 OLV campaign is pacing on plan and over-indexing on completion. Completion rate climbed from the low 60s in week one to the low 70s by week three as PGAM's optimization moved spend toward high-attention placements. Forty-eight allowlisted publishers, zero MFA leakage, and a full-funnel mid-funnel layer launched on June 3.</a:t>
+              <a:t>Amazon Business' Q2 OLV campaign is pacing on plan and over-indexing on completion. Completion rate climbed from the mid 60s in week one to the low 70s by week three as PGAM's optimization moved spend toward high-attention placements. Forty-eight allowlisted publishers, zero MFA leakage, and a full-funnel mid-funnel layer launched on June 3.</a:t>
             </a:r>
             <a:endParaRPr lang="en-US" sz="1400" dirty="0"/>
           </a:p>
@@ -7806,7 +7786,7 @@
         </p:nvGraphicFramePr>
         <p:xfrm>
           <a:off x="457200" y="1737360"/>
-          <a:ext cx="7498080" cy="4389120"/>
+          <a:ext cx="7498080" cy="4114800"/>
         </p:xfrm>
         <a:graphic xmlns:a="http://schemas.openxmlformats.org/drawingml/2006/main">
           <a:graphicData uri="http://schemas.openxmlformats.org/drawingml/2006/chart">
@@ -7823,7 +7803,7 @@
         <p:spPr>
           <a:xfrm>
             <a:off x="8183880" y="1737360"/>
-            <a:ext cx="3520440" cy="4389120"/>
+            <a:ext cx="3520440" cy="4114800"/>
           </a:xfrm>
           <a:prstGeom prst="rect">
             <a:avLst/>
@@ -7881,8 +7861,8 @@
         </p:nvSpPr>
         <p:spPr>
           <a:xfrm>
-            <a:off x="8366760" y="2331720"/>
-            <a:ext cx="3200400" cy="548640"/>
+            <a:off x="8366760" y="2286000"/>
+            <a:ext cx="3200400" cy="502920"/>
           </a:xfrm>
           <a:prstGeom prst="rect">
             <a:avLst/>
@@ -7898,7 +7878,7 @@
               <a:buNone/>
             </a:pPr>
             <a:r>
-              <a:rPr lang="en-US" sz="2800" b="1" dirty="0">
+              <a:rPr lang="en-US" sz="2600" b="1" dirty="0">
                 <a:solidFill>
                   <a:srgbClr val="F2A900"/>
                 </a:solidFill>
@@ -7908,7 +7888,7 @@
               </a:rPr>
               <a:t>+2.5 pp</a:t>
             </a:r>
-            <a:endParaRPr lang="en-US" sz="2800" dirty="0"/>
+            <a:endParaRPr lang="en-US" sz="2600" dirty="0"/>
           </a:p>
         </p:txBody>
       </p:sp>
@@ -7920,7 +7900,7 @@
         </p:nvSpPr>
         <p:spPr>
           <a:xfrm>
-            <a:off x="8366760" y="2926080"/>
+            <a:off x="8366760" y="2834640"/>
             <a:ext cx="3200400" cy="548640"/>
           </a:xfrm>
           <a:prstGeom prst="rect">
@@ -7948,7 +7928,7 @@
                 <a:ea typeface="Calibri" pitchFamily="34" charset="-122"/>
                 <a:cs typeface="Calibri" pitchFamily="34" charset="-120"/>
               </a:rPr>
-              <a:t>above IAB OLV completion benchmark</a:t>
+              <a:t>above IAB OLV completion benchmark on full-flight average</a:t>
             </a:r>
             <a:endParaRPr lang="en-US" sz="1100" dirty="0"/>
           </a:p>
@@ -7962,8 +7942,8 @@
         </p:nvSpPr>
         <p:spPr>
           <a:xfrm>
-            <a:off x="8366760" y="3566160"/>
-            <a:ext cx="3200400" cy="548640"/>
+            <a:off x="8366760" y="3429000"/>
+            <a:ext cx="3200400" cy="502920"/>
           </a:xfrm>
           <a:prstGeom prst="rect">
             <a:avLst/>
@@ -7979,7 +7959,7 @@
               <a:buNone/>
             </a:pPr>
             <a:r>
-              <a:rPr lang="en-US" sz="2800" b="1" dirty="0">
+              <a:rPr lang="en-US" sz="2600" b="1" dirty="0">
                 <a:solidFill>
                   <a:srgbClr val="F2A900"/>
                 </a:solidFill>
@@ -7987,9 +7967,9 @@
                 <a:ea typeface="Georgia" pitchFamily="34" charset="-122"/>
                 <a:cs typeface="Georgia" pitchFamily="34" charset="-120"/>
               </a:rPr>
-              <a:t>60.5</a:t>
-            </a:r>
-            <a:endParaRPr lang="en-US" sz="2800" dirty="0"/>
+              <a:t>+6.6 pp</a:t>
+            </a:r>
+            <a:endParaRPr lang="en-US" sz="2600" dirty="0"/>
           </a:p>
         </p:txBody>
       </p:sp>
@@ -8001,7 +7981,7 @@
         </p:nvSpPr>
         <p:spPr>
           <a:xfrm>
-            <a:off x="8366760" y="4160520"/>
+            <a:off x="8366760" y="3977640"/>
             <a:ext cx="3200400" cy="548640"/>
           </a:xfrm>
           <a:prstGeom prst="rect">
@@ -8029,7 +8009,7 @@
                 <a:ea typeface="Calibri" pitchFamily="34" charset="-122"/>
                 <a:cs typeface="Calibri" pitchFamily="34" charset="-120"/>
               </a:rPr>
-              <a:t>average PGAM Attention score (0–100)</a:t>
+              <a:t>above benchmark by week 3 as optimization compounded</a:t>
             </a:r>
             <a:endParaRPr lang="en-US" sz="1100" dirty="0"/>
           </a:p>
@@ -8043,8 +8023,8 @@
         </p:nvSpPr>
         <p:spPr>
           <a:xfrm>
-            <a:off x="8366760" y="4800600"/>
-            <a:ext cx="3200400" cy="548640"/>
+            <a:off x="8366760" y="4572000"/>
+            <a:ext cx="3200400" cy="502920"/>
           </a:xfrm>
           <a:prstGeom prst="rect">
             <a:avLst/>
@@ -8060,7 +8040,7 @@
               <a:buNone/>
             </a:pPr>
             <a:r>
-              <a:rPr lang="en-US" sz="2800" b="1" dirty="0">
+              <a:rPr lang="en-US" sz="2600" b="1" dirty="0">
                 <a:solidFill>
                   <a:srgbClr val="F2A900"/>
                 </a:solidFill>
@@ -8068,9 +8048,9 @@
                 <a:ea typeface="Georgia" pitchFamily="34" charset="-122"/>
                 <a:cs typeface="Georgia" pitchFamily="34" charset="-120"/>
               </a:rPr>
-              <a:t>100%</a:t>
-            </a:r>
-            <a:endParaRPr lang="en-US" sz="2800" dirty="0"/>
+              <a:t>60.5</a:t>
+            </a:r>
+            <a:endParaRPr lang="en-US" sz="2600" dirty="0"/>
           </a:p>
         </p:txBody>
       </p:sp>
@@ -8082,7 +8062,7 @@
         </p:nvSpPr>
         <p:spPr>
           <a:xfrm>
-            <a:off x="8366760" y="5394960"/>
+            <a:off x="8366760" y="5120640"/>
             <a:ext cx="3200400" cy="548640"/>
           </a:xfrm>
           <a:prstGeom prst="rect">
@@ -8110,7 +8090,7 @@
                 <a:ea typeface="Calibri" pitchFamily="34" charset="-122"/>
                 <a:cs typeface="Calibri" pitchFamily="34" charset="-120"/>
               </a:rPr>
-              <a:t>supply on advertiser-approved allowlist</a:t>
+              <a:t>average PGAM Attention score (0–100)</a:t>
             </a:r>
             <a:endParaRPr lang="en-US" sz="1100" dirty="0"/>
           </a:p>
@@ -8124,7 +8104,7 @@
         </p:nvSpPr>
         <p:spPr>
           <a:xfrm>
-            <a:off x="457200" y="6263640"/>
+            <a:off x="457200" y="5989320"/>
             <a:ext cx="11277295" cy="228600"/>
           </a:xfrm>
           <a:prstGeom prst="rect">
@@ -8149,7 +8129,7 @@
                 <a:ea typeface="Calibri" pitchFamily="34" charset="-122"/>
                 <a:cs typeface="Calibri" pitchFamily="34" charset="-120"/>
               </a:rPr>
-              <a:t>IAB OLV benchmark: industry average 62–68% completion for in-stream desktop+CTV video.</a:t>
+              <a:t>IAB OLV benchmark: industry average ~64% completion for in-stream desktop+CTV video.</a:t>
             </a:r>
             <a:endParaRPr lang="en-US" sz="900" dirty="0"/>
           </a:p>
@@ -13076,7 +13056,7 @@
         </p:nvSpPr>
         <p:spPr>
           <a:xfrm>
-            <a:off x="7132320" y="3108960"/>
+            <a:off x="7132320" y="2926080"/>
             <a:ext cx="548640" cy="548640"/>
           </a:xfrm>
           <a:prstGeom prst="ellipse">
@@ -13096,7 +13076,7 @@
         </p:nvSpPr>
         <p:spPr>
           <a:xfrm>
-            <a:off x="7132320" y="3108960"/>
+            <a:off x="7132320" y="2926080"/>
             <a:ext cx="548640" cy="548640"/>
           </a:xfrm>
           <a:prstGeom prst="rect">
@@ -13135,7 +13115,7 @@
         </p:nvSpPr>
         <p:spPr>
           <a:xfrm>
-            <a:off x="7818120" y="3127248"/>
+            <a:off x="7818120" y="2944368"/>
             <a:ext cx="3657600" cy="274320"/>
           </a:xfrm>
           <a:prstGeom prst="rect">
@@ -13174,7 +13154,7 @@
         </p:nvSpPr>
         <p:spPr>
           <a:xfrm>
-            <a:off x="7818120" y="3401568"/>
+            <a:off x="7818120" y="3218688"/>
             <a:ext cx="3657600" cy="457200"/>
           </a:xfrm>
           <a:prstGeom prst="rect">
@@ -13216,7 +13196,7 @@
         </p:nvSpPr>
         <p:spPr>
           <a:xfrm>
-            <a:off x="7132320" y="4023360"/>
+            <a:off x="7132320" y="3886200"/>
             <a:ext cx="548640" cy="548640"/>
           </a:xfrm>
           <a:prstGeom prst="ellipse">
@@ -13236,7 +13216,7 @@
         </p:nvSpPr>
         <p:spPr>
           <a:xfrm>
-            <a:off x="7132320" y="4023360"/>
+            <a:off x="7132320" y="3886200"/>
             <a:ext cx="548640" cy="548640"/>
           </a:xfrm>
           <a:prstGeom prst="rect">
@@ -13275,7 +13255,7 @@
         </p:nvSpPr>
         <p:spPr>
           <a:xfrm>
-            <a:off x="7818120" y="4041648"/>
+            <a:off x="7818120" y="3904488"/>
             <a:ext cx="3657600" cy="274320"/>
           </a:xfrm>
           <a:prstGeom prst="rect">
@@ -13314,7 +13294,7 @@
         </p:nvSpPr>
         <p:spPr>
           <a:xfrm>
-            <a:off x="7818120" y="4315968"/>
+            <a:off x="7818120" y="4178808"/>
             <a:ext cx="3657600" cy="457200"/>
           </a:xfrm>
           <a:prstGeom prst="rect">
@@ -13356,7 +13336,7 @@
         </p:nvSpPr>
         <p:spPr>
           <a:xfrm>
-            <a:off x="7132320" y="4937760"/>
+            <a:off x="7132320" y="4846320"/>
             <a:ext cx="548640" cy="548640"/>
           </a:xfrm>
           <a:prstGeom prst="ellipse">
@@ -13376,7 +13356,7 @@
         </p:nvSpPr>
         <p:spPr>
           <a:xfrm>
-            <a:off x="7132320" y="4937760"/>
+            <a:off x="7132320" y="4846320"/>
             <a:ext cx="548640" cy="548640"/>
           </a:xfrm>
           <a:prstGeom prst="rect">
@@ -13415,7 +13395,7 @@
         </p:nvSpPr>
         <p:spPr>
           <a:xfrm>
-            <a:off x="7818120" y="4956048"/>
+            <a:off x="7818120" y="4864608"/>
             <a:ext cx="3657600" cy="274320"/>
           </a:xfrm>
           <a:prstGeom prst="rect">
@@ -13454,7 +13434,7 @@
         </p:nvSpPr>
         <p:spPr>
           <a:xfrm>
-            <a:off x="7818120" y="5230368"/>
+            <a:off x="7818120" y="5138928"/>
             <a:ext cx="3657600" cy="457200"/>
           </a:xfrm>
           <a:prstGeom prst="rect">
@@ -13727,8 +13707,8 @@
         </p:nvSpPr>
         <p:spPr>
           <a:xfrm>
-            <a:off x="1066648" y="1737360"/>
-            <a:ext cx="10058400" cy="1234440"/>
+            <a:off x="1066648" y="1508760"/>
+            <a:ext cx="10058400" cy="1371600"/>
           </a:xfrm>
           <a:prstGeom prst="rect">
             <a:avLst/>
@@ -13759,8 +13739,8 @@
         </p:nvSpPr>
         <p:spPr>
           <a:xfrm>
-            <a:off x="1066648" y="1737360"/>
-            <a:ext cx="109728" cy="1234440"/>
+            <a:off x="1066648" y="1508760"/>
+            <a:ext cx="109728" cy="1371600"/>
           </a:xfrm>
           <a:prstGeom prst="rect">
             <a:avLst/>
@@ -13779,7 +13759,7 @@
         </p:nvSpPr>
         <p:spPr>
           <a:xfrm>
-            <a:off x="1340968" y="1847088"/>
+            <a:off x="1340968" y="1618488"/>
             <a:ext cx="2743200" cy="274320"/>
           </a:xfrm>
           <a:prstGeom prst="rect">
@@ -13818,8 +13798,8 @@
         </p:nvSpPr>
         <p:spPr>
           <a:xfrm>
-            <a:off x="1340968" y="2103120"/>
-            <a:ext cx="9601200" cy="411480"/>
+            <a:off x="1340968" y="1874520"/>
+            <a:ext cx="9601200" cy="365760"/>
           </a:xfrm>
           <a:prstGeom prst="rect">
             <a:avLst/>
@@ -13835,7 +13815,7 @@
               <a:buNone/>
             </a:pPr>
             <a:r>
-              <a:rPr lang="en-US" sz="1700" b="1" dirty="0">
+              <a:rPr lang="en-US" sz="1600" b="1" dirty="0">
                 <a:solidFill>
                   <a:srgbClr val="0B1E3F"/>
                 </a:solidFill>
@@ -13845,7 +13825,7 @@
               </a:rPr>
               <a:t>Q2 OLV — Brand awareness</a:t>
             </a:r>
-            <a:endParaRPr lang="en-US" sz="1700" dirty="0"/>
+            <a:endParaRPr lang="en-US" sz="1600" dirty="0"/>
           </a:p>
         </p:txBody>
       </p:sp>
@@ -13857,22 +13837,22 @@
         </p:nvSpPr>
         <p:spPr>
           <a:xfrm>
-            <a:off x="1340968" y="2487168"/>
-            <a:ext cx="6126480" cy="457200"/>
-          </a:xfrm>
-          <a:prstGeom prst="rect">
-            <a:avLst/>
-          </a:prstGeom>
-          <a:noFill/>
-          <a:ln/>
-        </p:spPr>
-        <p:txBody>
-          <a:bodyPr wrap="square" lIns="0" tIns="0" rIns="0" bIns="0" rtlCol="0" anchor="ctr"/>
+            <a:off x="1340968" y="2286000"/>
+            <a:ext cx="7132320" cy="502920"/>
+          </a:xfrm>
+          <a:prstGeom prst="rect">
+            <a:avLst/>
+          </a:prstGeom>
+          <a:noFill/>
+          <a:ln/>
+        </p:spPr>
+        <p:txBody>
+          <a:bodyPr wrap="square" lIns="0" tIns="0" rIns="0" bIns="0" rtlCol="0" anchor="t"/>
           <a:lstStyle/>
           <a:p>
             <a:pPr indent="0" marL="0">
               <a:lnSpc>
-                <a:spcPct val="130000"/>
+                <a:spcPct val="125000"/>
               </a:lnSpc>
               <a:buNone/>
             </a:pPr>
@@ -13899,8 +13879,8 @@
         </p:nvSpPr>
         <p:spPr>
           <a:xfrm>
-            <a:off x="7467448" y="2514600"/>
-            <a:ext cx="3383280" cy="365760"/>
+            <a:off x="8473288" y="2377440"/>
+            <a:ext cx="2468880" cy="365760"/>
           </a:xfrm>
           <a:prstGeom prst="rect">
             <a:avLst/>
@@ -13938,8 +13918,8 @@
         </p:nvSpPr>
         <p:spPr>
           <a:xfrm>
-            <a:off x="1981048" y="3154680"/>
-            <a:ext cx="8229600" cy="1234440"/>
+            <a:off x="1981048" y="3044952"/>
+            <a:ext cx="8229600" cy="1371600"/>
           </a:xfrm>
           <a:prstGeom prst="rect">
             <a:avLst/>
@@ -13970,8 +13950,8 @@
         </p:nvSpPr>
         <p:spPr>
           <a:xfrm>
-            <a:off x="1981048" y="3154680"/>
-            <a:ext cx="109728" cy="1234440"/>
+            <a:off x="1981048" y="3044952"/>
+            <a:ext cx="109728" cy="1371600"/>
           </a:xfrm>
           <a:prstGeom prst="rect">
             <a:avLst/>
@@ -13990,7 +13970,7 @@
         </p:nvSpPr>
         <p:spPr>
           <a:xfrm>
-            <a:off x="2255368" y="3264408"/>
+            <a:off x="2255368" y="3154680"/>
             <a:ext cx="2743200" cy="274320"/>
           </a:xfrm>
           <a:prstGeom prst="rect">
@@ -14029,8 +14009,8 @@
         </p:nvSpPr>
         <p:spPr>
           <a:xfrm>
-            <a:off x="2255368" y="3520440"/>
-            <a:ext cx="7772400" cy="411480"/>
+            <a:off x="2255368" y="3410712"/>
+            <a:ext cx="7772400" cy="365760"/>
           </a:xfrm>
           <a:prstGeom prst="rect">
             <a:avLst/>
@@ -14046,7 +14026,7 @@
               <a:buNone/>
             </a:pPr>
             <a:r>
-              <a:rPr lang="en-US" sz="1700" b="1" dirty="0">
+              <a:rPr lang="en-US" sz="1600" b="1" dirty="0">
                 <a:solidFill>
                   <a:srgbClr val="0B1E3F"/>
                 </a:solidFill>
@@ -14056,7 +14036,7 @@
               </a:rPr>
               <a:t>Q2 Mid-Funnel — Consideration</a:t>
             </a:r>
-            <a:endParaRPr lang="en-US" sz="1700" dirty="0"/>
+            <a:endParaRPr lang="en-US" sz="1600" dirty="0"/>
           </a:p>
         </p:txBody>
       </p:sp>
@@ -14068,22 +14048,22 @@
         </p:nvSpPr>
         <p:spPr>
           <a:xfrm>
-            <a:off x="2255368" y="3904488"/>
-            <a:ext cx="4297680" cy="457200"/>
-          </a:xfrm>
-          <a:prstGeom prst="rect">
-            <a:avLst/>
-          </a:prstGeom>
-          <a:noFill/>
-          <a:ln/>
-        </p:spPr>
-        <p:txBody>
-          <a:bodyPr wrap="square" lIns="0" tIns="0" rIns="0" bIns="0" rtlCol="0" anchor="ctr"/>
+            <a:off x="2255368" y="3822192"/>
+            <a:ext cx="5303520" cy="502920"/>
+          </a:xfrm>
+          <a:prstGeom prst="rect">
+            <a:avLst/>
+          </a:prstGeom>
+          <a:noFill/>
+          <a:ln/>
+        </p:spPr>
+        <p:txBody>
+          <a:bodyPr wrap="square" lIns="0" tIns="0" rIns="0" bIns="0" rtlCol="0" anchor="t"/>
           <a:lstStyle/>
           <a:p>
             <a:pPr indent="0" marL="0">
               <a:lnSpc>
-                <a:spcPct val="130000"/>
+                <a:spcPct val="125000"/>
               </a:lnSpc>
               <a:buNone/>
             </a:pPr>
@@ -14110,8 +14090,8 @@
         </p:nvSpPr>
         <p:spPr>
           <a:xfrm>
-            <a:off x="6553048" y="3931920"/>
-            <a:ext cx="3383280" cy="365760"/>
+            <a:off x="7558888" y="3913632"/>
+            <a:ext cx="2468880" cy="365760"/>
           </a:xfrm>
           <a:prstGeom prst="rect">
             <a:avLst/>
@@ -14149,8 +14129,8 @@
         </p:nvSpPr>
         <p:spPr>
           <a:xfrm>
-            <a:off x="2895448" y="4572000"/>
-            <a:ext cx="6400800" cy="1234440"/>
+            <a:off x="2895448" y="4581144"/>
+            <a:ext cx="6400800" cy="1371600"/>
           </a:xfrm>
           <a:prstGeom prst="rect">
             <a:avLst/>
@@ -14181,8 +14161,8 @@
         </p:nvSpPr>
         <p:spPr>
           <a:xfrm>
-            <a:off x="2895448" y="4572000"/>
-            <a:ext cx="109728" cy="1234440"/>
+            <a:off x="2895448" y="4581144"/>
+            <a:ext cx="109728" cy="1371600"/>
           </a:xfrm>
           <a:prstGeom prst="rect">
             <a:avLst/>
@@ -14201,7 +14181,7 @@
         </p:nvSpPr>
         <p:spPr>
           <a:xfrm>
-            <a:off x="3169768" y="4681728"/>
+            <a:off x="3169768" y="4690872"/>
             <a:ext cx="2743200" cy="274320"/>
           </a:xfrm>
           <a:prstGeom prst="rect">
@@ -14240,8 +14220,8 @@
         </p:nvSpPr>
         <p:spPr>
           <a:xfrm>
-            <a:off x="3169768" y="4937760"/>
-            <a:ext cx="5943600" cy="411480"/>
+            <a:off x="3169768" y="4946904"/>
+            <a:ext cx="5943600" cy="365760"/>
           </a:xfrm>
           <a:prstGeom prst="rect">
             <a:avLst/>
@@ -14257,7 +14237,7 @@
               <a:buNone/>
             </a:pPr>
             <a:r>
-              <a:rPr lang="en-US" sz="1700" b="1" dirty="0">
+              <a:rPr lang="en-US" sz="1600" b="1" dirty="0">
                 <a:solidFill>
                   <a:srgbClr val="0B1E3F"/>
                 </a:solidFill>
@@ -14267,7 +14247,7 @@
               </a:rPr>
               <a:t>Conversion / call attribution</a:t>
             </a:r>
-            <a:endParaRPr lang="en-US" sz="1700" dirty="0"/>
+            <a:endParaRPr lang="en-US" sz="1600" dirty="0"/>
           </a:p>
         </p:txBody>
       </p:sp>
@@ -14279,22 +14259,22 @@
         </p:nvSpPr>
         <p:spPr>
           <a:xfrm>
-            <a:off x="3169768" y="5321808"/>
-            <a:ext cx="2468880" cy="457200"/>
-          </a:xfrm>
-          <a:prstGeom prst="rect">
-            <a:avLst/>
-          </a:prstGeom>
-          <a:noFill/>
-          <a:ln/>
-        </p:spPr>
-        <p:txBody>
-          <a:bodyPr wrap="square" lIns="0" tIns="0" rIns="0" bIns="0" rtlCol="0" anchor="ctr"/>
+            <a:off x="3169768" y="5358384"/>
+            <a:ext cx="3474720" cy="502920"/>
+          </a:xfrm>
+          <a:prstGeom prst="rect">
+            <a:avLst/>
+          </a:prstGeom>
+          <a:noFill/>
+          <a:ln/>
+        </p:spPr>
+        <p:txBody>
+          <a:bodyPr wrap="square" lIns="0" tIns="0" rIns="0" bIns="0" rtlCol="0" anchor="t"/>
           <a:lstStyle/>
           <a:p>
             <a:pPr indent="0" marL="0">
               <a:lnSpc>
-                <a:spcPct val="130000"/>
+                <a:spcPct val="125000"/>
               </a:lnSpc>
               <a:buNone/>
             </a:pPr>
@@ -14321,8 +14301,8 @@
         </p:nvSpPr>
         <p:spPr>
           <a:xfrm>
-            <a:off x="5638648" y="5349240"/>
-            <a:ext cx="3383280" cy="365760"/>
+            <a:off x="6644488" y="5449824"/>
+            <a:ext cx="2468880" cy="365760"/>
           </a:xfrm>
           <a:prstGeom prst="rect">
             <a:avLst/>
@@ -14360,8 +14340,8 @@
         </p:nvSpPr>
         <p:spPr>
           <a:xfrm>
-            <a:off x="457200" y="6080760"/>
-            <a:ext cx="11277295" cy="365760"/>
+            <a:off x="457200" y="6172200"/>
+            <a:ext cx="11277295" cy="274320"/>
           </a:xfrm>
           <a:prstGeom prst="rect">
             <a:avLst/>
@@ -14377,7 +14357,7 @@
               <a:buNone/>
             </a:pPr>
             <a:r>
-              <a:rPr lang="en-US" sz="1100" i="1" dirty="0">
+              <a:rPr lang="en-US" sz="1000" i="1" dirty="0">
                 <a:solidFill>
                   <a:srgbClr val="64748B"/>
                 </a:solidFill>
@@ -14387,7 +14367,7 @@
               </a:rPr>
               <a:t>Full-funnel architecture means every upper-funnel completion has somewhere to go. Mid-funnel launched June 3 to absorb the audience PGAM just paid to reach.</a:t>
             </a:r>
-            <a:endParaRPr lang="en-US" sz="1100" dirty="0"/>
+            <a:endParaRPr lang="en-US" sz="1000" dirty="0"/>
           </a:p>
         </p:txBody>
       </p:sp>

</xml_diff>